<commit_message>
Lezioni 4 (EC2) e 5 (Tailscale) al posto della Client VPN; riferimenti aggiornati
</commit_message>
<xml_diff>
--- a/slide/slide-1-iam.pptx
+++ b/slide/slide-1-iam.pptx
@@ -1576,7 +1576,7 @@
           <a:p>
             <a:r>
               <a:rPr lang="en-US" dirty="0"/>
-              <a:t>Prima di cominciare, sei parole che useremo continuamente. L'account è il vostro spazio in AWS, identificato da un numero di dodici cifre. Un'API è una richiesta fatta ad AWS: ogni clic in console, ogni comando, ogni apply diventa una richiesta. S3 è l'archivio di file di AWS: un bucket è un contenitore, un oggetto è un file. EC2 è un server in AWS, lo vediamo nella lezione 5. Una policy è un documento con delle regole di permesso.</a:t>
+              <a:t>Prima di cominciare, sei parole che useremo continuamente. L'account è il vostro spazio in AWS, identificato da un numero di dodici cifre. Un'API è una richiesta fatta ad AWS: ogni clic in console, ogni comando, ogni apply diventa una richiesta. S3 è l'archivio di file di AWS: un bucket è un contenitore, un oggetto è un file. EC2 è un server in AWS, lo vediamo nella lezione 4. Una policy è un documento con delle regole di permesso.</a:t>
             </a:r>
             <a:endParaRPr lang="en-US" dirty="0"/>
           </a:p>
@@ -13145,7 +13145,7 @@
                 <a:ea typeface="Calibri" pitchFamily="34" charset="-122"/>
                 <a:cs typeface="Calibri" pitchFamily="34" charset="-120"/>
               </a:rPr>
-              <a:t>un server in AWS (lezione 5)</a:t>
+              <a:t>un server in AWS (lezione 4)</a:t>
             </a:r>
             <a:endParaRPr lang="en-US" sz="1600" dirty="0"/>
           </a:p>

</xml_diff>

<commit_message>
Slide 1 e 4 allineate alle dispense (condizione MFA; SSM e systemd)
</commit_message>
<xml_diff>
--- a/slide/slide-1-iam.pptx
+++ b/slide/slide-1-iam.pptx
@@ -1664,7 +1664,7 @@
           <a:p>
             <a:r>
               <a:rPr lang="en-US" dirty="0"/>
-              <a:t>Ogni volta che qualcuno chiede qualcosa ad AWS, IAM si fa sempre la stessa domanda, in quattro parti: chi lo chiede, cosa vuole fare, su quale cosa, e a quali condizioni. Nel nostro esempio: l'applicazione vuole leggere il file app-v1.0.txt, solo dalla nostra rete. IAM guarda le regole e risponde sì o no. Nelle policy le quattro parti hanno nomi inglesi: principal, action, resource, condition.</a:t>
+              <a:t>Ogni volta che qualcuno chiede qualcosa ad AWS, IAM si fa sempre la stessa domanda, in quattro parti: chi lo chiede, cosa vuole fare, su quale cosa, e a quali condizioni. Nel nostro esempio: l'applicazione vuole leggere il file app-v1.0.txt, solo se ha fatto login con MFA. IAM guarda le regole e risponde sì o no. Nelle policy le quattro parti hanno nomi inglesi: principal, action, resource, condition.</a:t>
             </a:r>
             <a:endParaRPr lang="en-US" dirty="0"/>
           </a:p>
@@ -14193,7 +14193,7 @@
                 <a:ea typeface="Calibri" pitchFamily="34" charset="-122"/>
                 <a:cs typeface="Calibri" pitchFamily="34" charset="-120"/>
               </a:rPr>
-              <a:t>solo dalla nostra rete</a:t>
+              <a:t>solo con login MFA</a:t>
             </a:r>
             <a:endParaRPr lang="en-US" sz="1700" dirty="0"/>
           </a:p>

</xml_diff>